<commit_message>
prepare dashboard for Railway deployment
</commit_message>
<xml_diff>
--- a/StockPulse簡報.pptx
+++ b/StockPulse簡報.pptx
@@ -5,17 +5,16 @@
     <p:sldMasterId id="2147483648" r:id="rId1"/>
   </p:sldMasterIdLst>
   <p:sldIdLst>
-    <p:sldId id="256" r:id="rId7"/>
-    <p:sldId id="257" r:id="rId8"/>
-    <p:sldId id="258" r:id="rId9"/>
-    <p:sldId id="259" r:id="rId10"/>
-    <p:sldId id="260" r:id="rId11"/>
-    <p:sldId id="261" r:id="rId12"/>
-    <p:sldId id="262" r:id="rId13"/>
-    <p:sldId id="263" r:id="rId14"/>
-    <p:sldId id="264" r:id="rId15"/>
+    <p:sldId id="256" r:id="rId2"/>
+    <p:sldId id="257" r:id="rId3"/>
+    <p:sldId id="258" r:id="rId4"/>
+    <p:sldId id="259" r:id="rId5"/>
+    <p:sldId id="260" r:id="rId6"/>
+    <p:sldId id="261" r:id="rId7"/>
+    <p:sldId id="262" r:id="rId8"/>
+    <p:sldId id="263" r:id="rId9"/>
   </p:sldIdLst>
-  <p:sldSz cx="12188952" cy="6858000" type="screen4x3"/>
+  <p:sldSz cx="12188825" cy="6858000"/>
   <p:notesSz cx="6858000" cy="9144000"/>
   <p:defaultTextStyle>
     <a:defPPr>
@@ -112,6 +111,22 @@
       </a:defRPr>
     </a:lvl9pPr>
   </p:defaultTextStyle>
+  <p:extLst>
+    <p:ext uri="{EFAFB233-063F-42B5-8137-9DF3F51BA10A}">
+      <p15:sldGuideLst xmlns:p15="http://schemas.microsoft.com/office/powerpoint/2012/main">
+        <p15:guide id="1" orient="horz" pos="2160">
+          <p15:clr>
+            <a:srgbClr val="A4A3A4"/>
+          </p15:clr>
+        </p15:guide>
+        <p15:guide id="2" pos="2880">
+          <p15:clr>
+            <a:srgbClr val="A4A3A4"/>
+          </p15:clr>
+        </p15:guide>
+      </p15:sldGuideLst>
+    </p:ext>
+  </p:extLst>
 </p:presentation>
 </file>
 
@@ -153,10 +168,9 @@
           <a:lstStyle/>
           <a:p>
             <a:r>
-              <a:rPr lang="en-US" smtClean="0"/>
+              <a:rPr lang="en-US"/>
               <a:t>Click to edit Master title style</a:t>
             </a:r>
-            <a:endParaRPr lang="en-US"/>
           </a:p>
         </p:txBody>
       </p:sp>
@@ -272,10 +286,9 @@
           </a:lstStyle>
           <a:p>
             <a:r>
-              <a:rPr lang="en-US" smtClean="0"/>
+              <a:rPr lang="en-US"/>
               <a:t>Click to edit Master subtitle style</a:t>
             </a:r>
-            <a:endParaRPr lang="en-US"/>
           </a:p>
         </p:txBody>
       </p:sp>
@@ -296,7 +309,7 @@
           <a:p>
             <a:fld id="{5BCAD085-E8A6-8845-BD4E-CB4CCA059FC4}" type="datetimeFigureOut">
               <a:rPr lang="en-US" smtClean="0"/>
-              <a:t>1/27/13</a:t>
+              <a:t>5/10/2026</a:t>
             </a:fld>
             <a:endParaRPr lang="en-US"/>
           </a:p>
@@ -390,10 +403,9 @@
           <a:lstStyle/>
           <a:p>
             <a:r>
-              <a:rPr lang="en-US" smtClean="0"/>
+              <a:rPr lang="en-US"/>
               <a:t>Click to edit Master title style</a:t>
             </a:r>
-            <a:endParaRPr lang="en-US"/>
           </a:p>
         </p:txBody>
       </p:sp>
@@ -414,38 +426,37 @@
           <a:p>
             <a:pPr lvl="0"/>
             <a:r>
-              <a:rPr lang="en-US" smtClean="0"/>
+              <a:rPr lang="en-US"/>
               <a:t>Click to edit Master text styles</a:t>
             </a:r>
           </a:p>
           <a:p>
             <a:pPr lvl="1"/>
             <a:r>
-              <a:rPr lang="en-US" smtClean="0"/>
+              <a:rPr lang="en-US"/>
               <a:t>Second level</a:t>
             </a:r>
           </a:p>
           <a:p>
             <a:pPr lvl="2"/>
             <a:r>
-              <a:rPr lang="en-US" smtClean="0"/>
+              <a:rPr lang="en-US"/>
               <a:t>Third level</a:t>
             </a:r>
           </a:p>
           <a:p>
             <a:pPr lvl="3"/>
             <a:r>
-              <a:rPr lang="en-US" smtClean="0"/>
+              <a:rPr lang="en-US"/>
               <a:t>Fourth level</a:t>
             </a:r>
           </a:p>
           <a:p>
             <a:pPr lvl="4"/>
             <a:r>
-              <a:rPr lang="en-US" smtClean="0"/>
+              <a:rPr lang="en-US"/>
               <a:t>Fifth level</a:t>
             </a:r>
-            <a:endParaRPr lang="en-US"/>
           </a:p>
         </p:txBody>
       </p:sp>
@@ -466,7 +477,7 @@
           <a:p>
             <a:fld id="{5BCAD085-E8A6-8845-BD4E-CB4CCA059FC4}" type="datetimeFigureOut">
               <a:rPr lang="en-US" smtClean="0"/>
-              <a:t>1/27/13</a:t>
+              <a:t>5/10/2026</a:t>
             </a:fld>
             <a:endParaRPr lang="en-US"/>
           </a:p>
@@ -565,10 +576,9 @@
           <a:lstStyle/>
           <a:p>
             <a:r>
-              <a:rPr lang="en-US" smtClean="0"/>
+              <a:rPr lang="en-US"/>
               <a:t>Click to edit Master title style</a:t>
             </a:r>
-            <a:endParaRPr lang="en-US"/>
           </a:p>
         </p:txBody>
       </p:sp>
@@ -594,38 +604,37 @@
           <a:p>
             <a:pPr lvl="0"/>
             <a:r>
-              <a:rPr lang="en-US" smtClean="0"/>
+              <a:rPr lang="en-US"/>
               <a:t>Click to edit Master text styles</a:t>
             </a:r>
           </a:p>
           <a:p>
             <a:pPr lvl="1"/>
             <a:r>
-              <a:rPr lang="en-US" smtClean="0"/>
+              <a:rPr lang="en-US"/>
               <a:t>Second level</a:t>
             </a:r>
           </a:p>
           <a:p>
             <a:pPr lvl="2"/>
             <a:r>
-              <a:rPr lang="en-US" smtClean="0"/>
+              <a:rPr lang="en-US"/>
               <a:t>Third level</a:t>
             </a:r>
           </a:p>
           <a:p>
             <a:pPr lvl="3"/>
             <a:r>
-              <a:rPr lang="en-US" smtClean="0"/>
+              <a:rPr lang="en-US"/>
               <a:t>Fourth level</a:t>
             </a:r>
           </a:p>
           <a:p>
             <a:pPr lvl="4"/>
             <a:r>
-              <a:rPr lang="en-US" smtClean="0"/>
+              <a:rPr lang="en-US"/>
               <a:t>Fifth level</a:t>
             </a:r>
-            <a:endParaRPr lang="en-US"/>
           </a:p>
         </p:txBody>
       </p:sp>
@@ -646,7 +655,7 @@
           <a:p>
             <a:fld id="{5BCAD085-E8A6-8845-BD4E-CB4CCA059FC4}" type="datetimeFigureOut">
               <a:rPr lang="en-US" smtClean="0"/>
-              <a:t>1/27/13</a:t>
+              <a:t>5/10/2026</a:t>
             </a:fld>
             <a:endParaRPr lang="en-US"/>
           </a:p>
@@ -740,10 +749,9 @@
           <a:lstStyle/>
           <a:p>
             <a:r>
-              <a:rPr lang="en-US" smtClean="0"/>
+              <a:rPr lang="en-US"/>
               <a:t>Click to edit Master title style</a:t>
             </a:r>
-            <a:endParaRPr lang="en-US"/>
           </a:p>
         </p:txBody>
       </p:sp>
@@ -764,38 +772,37 @@
           <a:p>
             <a:pPr lvl="0"/>
             <a:r>
-              <a:rPr lang="en-US" smtClean="0"/>
+              <a:rPr lang="en-US"/>
               <a:t>Click to edit Master text styles</a:t>
             </a:r>
           </a:p>
           <a:p>
             <a:pPr lvl="1"/>
             <a:r>
-              <a:rPr lang="en-US" smtClean="0"/>
+              <a:rPr lang="en-US"/>
               <a:t>Second level</a:t>
             </a:r>
           </a:p>
           <a:p>
             <a:pPr lvl="2"/>
             <a:r>
-              <a:rPr lang="en-US" smtClean="0"/>
+              <a:rPr lang="en-US"/>
               <a:t>Third level</a:t>
             </a:r>
           </a:p>
           <a:p>
             <a:pPr lvl="3"/>
             <a:r>
-              <a:rPr lang="en-US" smtClean="0"/>
+              <a:rPr lang="en-US"/>
               <a:t>Fourth level</a:t>
             </a:r>
           </a:p>
           <a:p>
             <a:pPr lvl="4"/>
             <a:r>
-              <a:rPr lang="en-US" smtClean="0"/>
+              <a:rPr lang="en-US"/>
               <a:t>Fifth level</a:t>
             </a:r>
-            <a:endParaRPr lang="en-US"/>
           </a:p>
         </p:txBody>
       </p:sp>
@@ -816,7 +823,7 @@
           <a:p>
             <a:fld id="{5BCAD085-E8A6-8845-BD4E-CB4CCA059FC4}" type="datetimeFigureOut">
               <a:rPr lang="en-US" smtClean="0"/>
-              <a:t>1/27/13</a:t>
+              <a:t>5/10/2026</a:t>
             </a:fld>
             <a:endParaRPr lang="en-US"/>
           </a:p>
@@ -919,10 +926,9 @@
           </a:lstStyle>
           <a:p>
             <a:r>
-              <a:rPr lang="en-US" smtClean="0"/>
+              <a:rPr lang="en-US"/>
               <a:t>Click to edit Master title style</a:t>
             </a:r>
-            <a:endParaRPr lang="en-US"/>
           </a:p>
         </p:txBody>
       </p:sp>
@@ -1039,7 +1045,7 @@
           <a:p>
             <a:pPr lvl="0"/>
             <a:r>
-              <a:rPr lang="en-US" smtClean="0"/>
+              <a:rPr lang="en-US"/>
               <a:t>Click to edit Master text styles</a:t>
             </a:r>
           </a:p>
@@ -1062,7 +1068,7 @@
           <a:p>
             <a:fld id="{5BCAD085-E8A6-8845-BD4E-CB4CCA059FC4}" type="datetimeFigureOut">
               <a:rPr lang="en-US" smtClean="0"/>
-              <a:t>1/27/13</a:t>
+              <a:t>5/10/2026</a:t>
             </a:fld>
             <a:endParaRPr lang="en-US"/>
           </a:p>
@@ -1156,10 +1162,9 @@
           <a:lstStyle/>
           <a:p>
             <a:r>
-              <a:rPr lang="en-US" smtClean="0"/>
+              <a:rPr lang="en-US"/>
               <a:t>Click to edit Master title style</a:t>
             </a:r>
-            <a:endParaRPr lang="en-US"/>
           </a:p>
         </p:txBody>
       </p:sp>
@@ -1213,38 +1218,37 @@
           <a:p>
             <a:pPr lvl="0"/>
             <a:r>
-              <a:rPr lang="en-US" smtClean="0"/>
+              <a:rPr lang="en-US"/>
               <a:t>Click to edit Master text styles</a:t>
             </a:r>
           </a:p>
           <a:p>
             <a:pPr lvl="1"/>
             <a:r>
-              <a:rPr lang="en-US" smtClean="0"/>
+              <a:rPr lang="en-US"/>
               <a:t>Second level</a:t>
             </a:r>
           </a:p>
           <a:p>
             <a:pPr lvl="2"/>
             <a:r>
-              <a:rPr lang="en-US" smtClean="0"/>
+              <a:rPr lang="en-US"/>
               <a:t>Third level</a:t>
             </a:r>
           </a:p>
           <a:p>
             <a:pPr lvl="3"/>
             <a:r>
-              <a:rPr lang="en-US" smtClean="0"/>
+              <a:rPr lang="en-US"/>
               <a:t>Fourth level</a:t>
             </a:r>
           </a:p>
           <a:p>
             <a:pPr lvl="4"/>
             <a:r>
-              <a:rPr lang="en-US" smtClean="0"/>
+              <a:rPr lang="en-US"/>
               <a:t>Fifth level</a:t>
             </a:r>
-            <a:endParaRPr lang="en-US"/>
           </a:p>
         </p:txBody>
       </p:sp>
@@ -1298,38 +1302,37 @@
           <a:p>
             <a:pPr lvl="0"/>
             <a:r>
-              <a:rPr lang="en-US" smtClean="0"/>
+              <a:rPr lang="en-US"/>
               <a:t>Click to edit Master text styles</a:t>
             </a:r>
           </a:p>
           <a:p>
             <a:pPr lvl="1"/>
             <a:r>
-              <a:rPr lang="en-US" smtClean="0"/>
+              <a:rPr lang="en-US"/>
               <a:t>Second level</a:t>
             </a:r>
           </a:p>
           <a:p>
             <a:pPr lvl="2"/>
             <a:r>
-              <a:rPr lang="en-US" smtClean="0"/>
+              <a:rPr lang="en-US"/>
               <a:t>Third level</a:t>
             </a:r>
           </a:p>
           <a:p>
             <a:pPr lvl="3"/>
             <a:r>
-              <a:rPr lang="en-US" smtClean="0"/>
+              <a:rPr lang="en-US"/>
               <a:t>Fourth level</a:t>
             </a:r>
           </a:p>
           <a:p>
             <a:pPr lvl="4"/>
             <a:r>
-              <a:rPr lang="en-US" smtClean="0"/>
+              <a:rPr lang="en-US"/>
               <a:t>Fifth level</a:t>
             </a:r>
-            <a:endParaRPr lang="en-US"/>
           </a:p>
         </p:txBody>
       </p:sp>
@@ -1350,7 +1353,7 @@
           <a:p>
             <a:fld id="{5BCAD085-E8A6-8845-BD4E-CB4CCA059FC4}" type="datetimeFigureOut">
               <a:rPr lang="en-US" smtClean="0"/>
-              <a:t>1/27/13</a:t>
+              <a:t>5/10/2026</a:t>
             </a:fld>
             <a:endParaRPr lang="en-US"/>
           </a:p>
@@ -1448,10 +1451,9 @@
           </a:lstStyle>
           <a:p>
             <a:r>
-              <a:rPr lang="en-US" smtClean="0"/>
+              <a:rPr lang="en-US"/>
               <a:t>Click to edit Master title style</a:t>
             </a:r>
-            <a:endParaRPr lang="en-US"/>
           </a:p>
         </p:txBody>
       </p:sp>
@@ -1514,7 +1516,7 @@
           <a:p>
             <a:pPr lvl="0"/>
             <a:r>
-              <a:rPr lang="en-US" smtClean="0"/>
+              <a:rPr lang="en-US"/>
               <a:t>Click to edit Master text styles</a:t>
             </a:r>
           </a:p>
@@ -1570,38 +1572,37 @@
           <a:p>
             <a:pPr lvl="0"/>
             <a:r>
-              <a:rPr lang="en-US" smtClean="0"/>
+              <a:rPr lang="en-US"/>
               <a:t>Click to edit Master text styles</a:t>
             </a:r>
           </a:p>
           <a:p>
             <a:pPr lvl="1"/>
             <a:r>
-              <a:rPr lang="en-US" smtClean="0"/>
+              <a:rPr lang="en-US"/>
               <a:t>Second level</a:t>
             </a:r>
           </a:p>
           <a:p>
             <a:pPr lvl="2"/>
             <a:r>
-              <a:rPr lang="en-US" smtClean="0"/>
+              <a:rPr lang="en-US"/>
               <a:t>Third level</a:t>
             </a:r>
           </a:p>
           <a:p>
             <a:pPr lvl="3"/>
             <a:r>
-              <a:rPr lang="en-US" smtClean="0"/>
+              <a:rPr lang="en-US"/>
               <a:t>Fourth level</a:t>
             </a:r>
           </a:p>
           <a:p>
             <a:pPr lvl="4"/>
             <a:r>
-              <a:rPr lang="en-US" smtClean="0"/>
+              <a:rPr lang="en-US"/>
               <a:t>Fifth level</a:t>
             </a:r>
-            <a:endParaRPr lang="en-US"/>
           </a:p>
         </p:txBody>
       </p:sp>
@@ -1664,7 +1665,7 @@
           <a:p>
             <a:pPr lvl="0"/>
             <a:r>
-              <a:rPr lang="en-US" smtClean="0"/>
+              <a:rPr lang="en-US"/>
               <a:t>Click to edit Master text styles</a:t>
             </a:r>
           </a:p>
@@ -1720,38 +1721,37 @@
           <a:p>
             <a:pPr lvl="0"/>
             <a:r>
-              <a:rPr lang="en-US" smtClean="0"/>
+              <a:rPr lang="en-US"/>
               <a:t>Click to edit Master text styles</a:t>
             </a:r>
           </a:p>
           <a:p>
             <a:pPr lvl="1"/>
             <a:r>
-              <a:rPr lang="en-US" smtClean="0"/>
+              <a:rPr lang="en-US"/>
               <a:t>Second level</a:t>
             </a:r>
           </a:p>
           <a:p>
             <a:pPr lvl="2"/>
             <a:r>
-              <a:rPr lang="en-US" smtClean="0"/>
+              <a:rPr lang="en-US"/>
               <a:t>Third level</a:t>
             </a:r>
           </a:p>
           <a:p>
             <a:pPr lvl="3"/>
             <a:r>
-              <a:rPr lang="en-US" smtClean="0"/>
+              <a:rPr lang="en-US"/>
               <a:t>Fourth level</a:t>
             </a:r>
           </a:p>
           <a:p>
             <a:pPr lvl="4"/>
             <a:r>
-              <a:rPr lang="en-US" smtClean="0"/>
+              <a:rPr lang="en-US"/>
               <a:t>Fifth level</a:t>
             </a:r>
-            <a:endParaRPr lang="en-US"/>
           </a:p>
         </p:txBody>
       </p:sp>
@@ -1772,7 +1772,7 @@
           <a:p>
             <a:fld id="{5BCAD085-E8A6-8845-BD4E-CB4CCA059FC4}" type="datetimeFigureOut">
               <a:rPr lang="en-US" smtClean="0"/>
-              <a:t>1/27/13</a:t>
+              <a:t>5/10/2026</a:t>
             </a:fld>
             <a:endParaRPr lang="en-US"/>
           </a:p>
@@ -1866,10 +1866,9 @@
           <a:lstStyle/>
           <a:p>
             <a:r>
-              <a:rPr lang="en-US" smtClean="0"/>
+              <a:rPr lang="en-US"/>
               <a:t>Click to edit Master title style</a:t>
             </a:r>
-            <a:endParaRPr lang="en-US"/>
           </a:p>
         </p:txBody>
       </p:sp>
@@ -1890,7 +1889,7 @@
           <a:p>
             <a:fld id="{5BCAD085-E8A6-8845-BD4E-CB4CCA059FC4}" type="datetimeFigureOut">
               <a:rPr lang="en-US" smtClean="0"/>
-              <a:t>1/27/13</a:t>
+              <a:t>5/10/2026</a:t>
             </a:fld>
             <a:endParaRPr lang="en-US"/>
           </a:p>
@@ -1985,7 +1984,7 @@
           <a:p>
             <a:fld id="{5BCAD085-E8A6-8845-BD4E-CB4CCA059FC4}" type="datetimeFigureOut">
               <a:rPr lang="en-US" smtClean="0"/>
-              <a:t>1/27/13</a:t>
+              <a:t>5/10/2026</a:t>
             </a:fld>
             <a:endParaRPr lang="en-US"/>
           </a:p>
@@ -2088,10 +2087,9 @@
           </a:lstStyle>
           <a:p>
             <a:r>
-              <a:rPr lang="en-US" smtClean="0"/>
+              <a:rPr lang="en-US"/>
               <a:t>Click to edit Master title style</a:t>
             </a:r>
-            <a:endParaRPr lang="en-US"/>
           </a:p>
         </p:txBody>
       </p:sp>
@@ -2145,38 +2143,37 @@
           <a:p>
             <a:pPr lvl="0"/>
             <a:r>
-              <a:rPr lang="en-US" smtClean="0"/>
+              <a:rPr lang="en-US"/>
               <a:t>Click to edit Master text styles</a:t>
             </a:r>
           </a:p>
           <a:p>
             <a:pPr lvl="1"/>
             <a:r>
-              <a:rPr lang="en-US" smtClean="0"/>
+              <a:rPr lang="en-US"/>
               <a:t>Second level</a:t>
             </a:r>
           </a:p>
           <a:p>
             <a:pPr lvl="2"/>
             <a:r>
-              <a:rPr lang="en-US" smtClean="0"/>
+              <a:rPr lang="en-US"/>
               <a:t>Third level</a:t>
             </a:r>
           </a:p>
           <a:p>
             <a:pPr lvl="3"/>
             <a:r>
-              <a:rPr lang="en-US" smtClean="0"/>
+              <a:rPr lang="en-US"/>
               <a:t>Fourth level</a:t>
             </a:r>
           </a:p>
           <a:p>
             <a:pPr lvl="4"/>
             <a:r>
-              <a:rPr lang="en-US" smtClean="0"/>
+              <a:rPr lang="en-US"/>
               <a:t>Fifth level</a:t>
             </a:r>
-            <a:endParaRPr lang="en-US"/>
           </a:p>
         </p:txBody>
       </p:sp>
@@ -2239,7 +2236,7 @@
           <a:p>
             <a:pPr lvl="0"/>
             <a:r>
-              <a:rPr lang="en-US" smtClean="0"/>
+              <a:rPr lang="en-US"/>
               <a:t>Click to edit Master text styles</a:t>
             </a:r>
           </a:p>
@@ -2262,7 +2259,7 @@
           <a:p>
             <a:fld id="{5BCAD085-E8A6-8845-BD4E-CB4CCA059FC4}" type="datetimeFigureOut">
               <a:rPr lang="en-US" smtClean="0"/>
-              <a:t>1/27/13</a:t>
+              <a:t>5/10/2026</a:t>
             </a:fld>
             <a:endParaRPr lang="en-US"/>
           </a:p>
@@ -2365,10 +2362,9 @@
           </a:lstStyle>
           <a:p>
             <a:r>
-              <a:rPr lang="en-US" smtClean="0"/>
+              <a:rPr lang="en-US"/>
               <a:t>Click to edit Master title style</a:t>
             </a:r>
-            <a:endParaRPr lang="en-US"/>
           </a:p>
         </p:txBody>
       </p:sp>
@@ -2492,7 +2488,7 @@
           <a:p>
             <a:pPr lvl="0"/>
             <a:r>
-              <a:rPr lang="en-US" smtClean="0"/>
+              <a:rPr lang="en-US"/>
               <a:t>Click to edit Master text styles</a:t>
             </a:r>
           </a:p>
@@ -2515,7 +2511,7 @@
           <a:p>
             <a:fld id="{5BCAD085-E8A6-8845-BD4E-CB4CCA059FC4}" type="datetimeFigureOut">
               <a:rPr lang="en-US" smtClean="0"/>
-              <a:t>1/27/13</a:t>
+              <a:t>5/10/2026</a:t>
             </a:fld>
             <a:endParaRPr lang="en-US"/>
           </a:p>
@@ -2624,10 +2620,9 @@
           <a:lstStyle/>
           <a:p>
             <a:r>
-              <a:rPr lang="en-US" smtClean="0"/>
+              <a:rPr lang="en-US"/>
               <a:t>Click to edit Master title style</a:t>
             </a:r>
-            <a:endParaRPr lang="en-US"/>
           </a:p>
         </p:txBody>
       </p:sp>
@@ -2658,38 +2653,37 @@
           <a:p>
             <a:pPr lvl="0"/>
             <a:r>
-              <a:rPr lang="en-US" smtClean="0"/>
+              <a:rPr lang="en-US"/>
               <a:t>Click to edit Master text styles</a:t>
             </a:r>
           </a:p>
           <a:p>
             <a:pPr lvl="1"/>
             <a:r>
-              <a:rPr lang="en-US" smtClean="0"/>
+              <a:rPr lang="en-US"/>
               <a:t>Second level</a:t>
             </a:r>
           </a:p>
           <a:p>
             <a:pPr lvl="2"/>
             <a:r>
-              <a:rPr lang="en-US" smtClean="0"/>
+              <a:rPr lang="en-US"/>
               <a:t>Third level</a:t>
             </a:r>
           </a:p>
           <a:p>
             <a:pPr lvl="3"/>
             <a:r>
-              <a:rPr lang="en-US" smtClean="0"/>
+              <a:rPr lang="en-US"/>
               <a:t>Fourth level</a:t>
             </a:r>
           </a:p>
           <a:p>
             <a:pPr lvl="4"/>
             <a:r>
-              <a:rPr lang="en-US" smtClean="0"/>
+              <a:rPr lang="en-US"/>
               <a:t>Fifth level</a:t>
             </a:r>
-            <a:endParaRPr lang="en-US"/>
           </a:p>
         </p:txBody>
       </p:sp>
@@ -2728,7 +2722,7 @@
           <a:p>
             <a:fld id="{5BCAD085-E8A6-8845-BD4E-CB4CCA059FC4}" type="datetimeFigureOut">
               <a:rPr lang="en-US" smtClean="0"/>
-              <a:t>1/27/13</a:t>
+              <a:t>5/10/2026</a:t>
             </a:fld>
             <a:endParaRPr lang="en-US"/>
           </a:p>
@@ -3087,7 +3081,7 @@
 </file>
 
 <file path=ppt/slides/slide1.xml><?xml version="1.0" encoding="utf-8"?>
-<p:sld xmlns:a="http://schemas.openxmlformats.org/drawingml/2006/main" xmlns:p="http://schemas.openxmlformats.org/presentationml/2006/main" xmlns:r="http://schemas.openxmlformats.org/officeDocument/2006/relationships">
+<p:sld xmlns:a="http://schemas.openxmlformats.org/drawingml/2006/main" xmlns:r="http://schemas.openxmlformats.org/officeDocument/2006/relationships" xmlns:p="http://schemas.openxmlformats.org/presentationml/2006/main">
   <p:cSld>
     <p:bg>
       <p:bgPr>
@@ -3103,7 +3097,14 @@
         <p:cNvGrpSpPr/>
         <p:nvPr/>
       </p:nvGrpSpPr>
-      <p:grpSpPr/>
+      <p:grpSpPr>
+        <a:xfrm>
+          <a:off x="0" y="0"/>
+          <a:ext cx="0" cy="0"/>
+          <a:chOff x="0" y="0"/>
+          <a:chExt cx="0" cy="0"/>
+        </a:xfrm>
+      </p:grpSpPr>
       <p:sp>
         <p:nvSpPr>
           <p:cNvPr id="2" name="Rectangle 1"/>
@@ -3144,6 +3145,7 @@
           <a:lstStyle/>
           <a:p>
             <a:pPr algn="ctr"/>
+            <a:endParaRPr/>
           </a:p>
         </p:txBody>
       </p:sp>
@@ -3259,6 +3261,7 @@
           <a:lstStyle/>
           <a:p>
             <a:pPr algn="ctr"/>
+            <a:endParaRPr/>
           </a:p>
         </p:txBody>
       </p:sp>
@@ -3339,6 +3342,7 @@
           <a:lstStyle/>
           <a:p>
             <a:pPr algn="ctr"/>
+            <a:endParaRPr/>
           </a:p>
         </p:txBody>
       </p:sp>
@@ -3419,6 +3423,7 @@
           <a:lstStyle/>
           <a:p>
             <a:pPr algn="ctr"/>
+            <a:endParaRPr/>
           </a:p>
         </p:txBody>
       </p:sp>
@@ -3499,6 +3504,7 @@
           <a:lstStyle/>
           <a:p>
             <a:pPr algn="ctr"/>
+            <a:endParaRPr/>
           </a:p>
         </p:txBody>
       </p:sp>
@@ -3579,6 +3585,7 @@
           <a:lstStyle/>
           <a:p>
             <a:pPr algn="ctr"/>
+            <a:endParaRPr/>
           </a:p>
         </p:txBody>
       </p:sp>
@@ -3692,6 +3699,7 @@
           <a:lstStyle/>
           <a:p>
             <a:pPr algn="ctr"/>
+            <a:endParaRPr/>
           </a:p>
         </p:txBody>
       </p:sp>
@@ -3704,7 +3712,7 @@
 </file>
 
 <file path=ppt/slides/slide2.xml><?xml version="1.0" encoding="utf-8"?>
-<p:sld xmlns:a="http://schemas.openxmlformats.org/drawingml/2006/main" xmlns:p="http://schemas.openxmlformats.org/presentationml/2006/main" xmlns:r="http://schemas.openxmlformats.org/officeDocument/2006/relationships">
+<p:sld xmlns:a="http://schemas.openxmlformats.org/drawingml/2006/main" xmlns:r="http://schemas.openxmlformats.org/officeDocument/2006/relationships" xmlns:p="http://schemas.openxmlformats.org/presentationml/2006/main">
   <p:cSld>
     <p:bg>
       <p:bgPr>
@@ -3720,7 +3728,14 @@
         <p:cNvGrpSpPr/>
         <p:nvPr/>
       </p:nvGrpSpPr>
-      <p:grpSpPr/>
+      <p:grpSpPr>
+        <a:xfrm>
+          <a:off x="0" y="0"/>
+          <a:ext cx="0" cy="0"/>
+          <a:chOff x="0" y="0"/>
+          <a:chExt cx="0" cy="0"/>
+        </a:xfrm>
+      </p:grpSpPr>
       <p:sp>
         <p:nvSpPr>
           <p:cNvPr id="2" name="Rectangle 1"/>
@@ -3761,6 +3776,7 @@
           <a:lstStyle/>
           <a:p>
             <a:pPr algn="ctr"/>
+            <a:endParaRPr/>
           </a:p>
         </p:txBody>
       </p:sp>
@@ -3876,6 +3892,7 @@
           <a:lstStyle/>
           <a:p>
             <a:pPr algn="ctr"/>
+            <a:endParaRPr/>
           </a:p>
         </p:txBody>
       </p:sp>
@@ -3919,6 +3936,7 @@
           <a:lstStyle/>
           <a:p>
             <a:pPr algn="ctr"/>
+            <a:endParaRPr/>
           </a:p>
         </p:txBody>
       </p:sp>
@@ -4070,6 +4088,7 @@
           <a:lstStyle/>
           <a:p>
             <a:pPr algn="ctr"/>
+            <a:endParaRPr/>
           </a:p>
         </p:txBody>
       </p:sp>
@@ -4113,6 +4132,7 @@
           <a:lstStyle/>
           <a:p>
             <a:pPr algn="ctr"/>
+            <a:endParaRPr/>
           </a:p>
         </p:txBody>
       </p:sp>
@@ -4264,6 +4284,7 @@
           <a:lstStyle/>
           <a:p>
             <a:pPr algn="ctr"/>
+            <a:endParaRPr/>
           </a:p>
         </p:txBody>
       </p:sp>
@@ -4307,6 +4328,7 @@
           <a:lstStyle/>
           <a:p>
             <a:pPr algn="ctr"/>
+            <a:endParaRPr/>
           </a:p>
         </p:txBody>
       </p:sp>
@@ -4458,6 +4480,7 @@
           <a:lstStyle/>
           <a:p>
             <a:pPr algn="ctr"/>
+            <a:endParaRPr/>
           </a:p>
         </p:txBody>
       </p:sp>
@@ -4501,6 +4524,7 @@
           <a:lstStyle/>
           <a:p>
             <a:pPr algn="ctr"/>
+            <a:endParaRPr/>
           </a:p>
         </p:txBody>
       </p:sp>
@@ -4652,6 +4676,7 @@
           <a:lstStyle/>
           <a:p>
             <a:pPr algn="ctr"/>
+            <a:endParaRPr/>
           </a:p>
         </p:txBody>
       </p:sp>
@@ -4695,6 +4720,7 @@
           <a:lstStyle/>
           <a:p>
             <a:pPr algn="ctr"/>
+            <a:endParaRPr/>
           </a:p>
         </p:txBody>
       </p:sp>
@@ -4811,6 +4837,7 @@
           <a:lstStyle/>
           <a:p>
             <a:pPr algn="ctr"/>
+            <a:endParaRPr/>
           </a:p>
         </p:txBody>
       </p:sp>
@@ -4854,6 +4881,7 @@
           <a:lstStyle/>
           <a:p>
             <a:pPr algn="ctr"/>
+            <a:endParaRPr/>
           </a:p>
         </p:txBody>
       </p:sp>
@@ -4969,6 +4997,7 @@
           <a:lstStyle/>
           <a:p>
             <a:pPr algn="ctr"/>
+            <a:endParaRPr/>
           </a:p>
         </p:txBody>
       </p:sp>
@@ -5012,6 +5041,7 @@
           <a:lstStyle/>
           <a:p>
             <a:pPr algn="ctr"/>
+            <a:endParaRPr/>
           </a:p>
         </p:txBody>
       </p:sp>
@@ -5127,6 +5157,7 @@
           <a:lstStyle/>
           <a:p>
             <a:pPr algn="ctr"/>
+            <a:endParaRPr/>
           </a:p>
         </p:txBody>
       </p:sp>
@@ -5170,6 +5201,7 @@
           <a:lstStyle/>
           <a:p>
             <a:pPr algn="ctr"/>
+            <a:endParaRPr/>
           </a:p>
         </p:txBody>
       </p:sp>
@@ -5252,7 +5284,7 @@
 </file>
 
 <file path=ppt/slides/slide3.xml><?xml version="1.0" encoding="utf-8"?>
-<p:sld xmlns:a="http://schemas.openxmlformats.org/drawingml/2006/main" xmlns:p="http://schemas.openxmlformats.org/presentationml/2006/main" xmlns:r="http://schemas.openxmlformats.org/officeDocument/2006/relationships">
+<p:sld xmlns:a="http://schemas.openxmlformats.org/drawingml/2006/main" xmlns:r="http://schemas.openxmlformats.org/officeDocument/2006/relationships" xmlns:p="http://schemas.openxmlformats.org/presentationml/2006/main">
   <p:cSld>
     <p:bg>
       <p:bgPr>
@@ -5268,7 +5300,14 @@
         <p:cNvGrpSpPr/>
         <p:nvPr/>
       </p:nvGrpSpPr>
-      <p:grpSpPr/>
+      <p:grpSpPr>
+        <a:xfrm>
+          <a:off x="0" y="0"/>
+          <a:ext cx="0" cy="0"/>
+          <a:chOff x="0" y="0"/>
+          <a:chExt cx="0" cy="0"/>
+        </a:xfrm>
+      </p:grpSpPr>
       <p:sp>
         <p:nvSpPr>
           <p:cNvPr id="2" name="Rectangle 1"/>
@@ -5309,6 +5348,7 @@
           <a:lstStyle/>
           <a:p>
             <a:pPr algn="ctr"/>
+            <a:endParaRPr/>
           </a:p>
         </p:txBody>
       </p:sp>
@@ -5424,6 +5464,7 @@
           <a:lstStyle/>
           <a:p>
             <a:pPr algn="ctr"/>
+            <a:endParaRPr/>
           </a:p>
         </p:txBody>
       </p:sp>
@@ -5467,6 +5508,7 @@
           <a:lstStyle/>
           <a:p>
             <a:pPr algn="ctr"/>
+            <a:endParaRPr/>
           </a:p>
         </p:txBody>
       </p:sp>
@@ -5583,6 +5625,7 @@
           <a:lstStyle/>
           <a:p>
             <a:pPr algn="ctr"/>
+            <a:endParaRPr/>
           </a:p>
         </p:txBody>
       </p:sp>
@@ -5626,6 +5669,7 @@
           <a:lstStyle/>
           <a:p>
             <a:pPr algn="ctr"/>
+            <a:endParaRPr/>
           </a:p>
         </p:txBody>
       </p:sp>
@@ -5742,6 +5786,7 @@
           <a:lstStyle/>
           <a:p>
             <a:pPr algn="ctr"/>
+            <a:endParaRPr/>
           </a:p>
         </p:txBody>
       </p:sp>
@@ -5785,6 +5830,7 @@
           <a:lstStyle/>
           <a:p>
             <a:pPr algn="ctr"/>
+            <a:endParaRPr/>
           </a:p>
         </p:txBody>
       </p:sp>
@@ -5936,6 +5982,7 @@
           <a:lstStyle/>
           <a:p>
             <a:pPr algn="ctr"/>
+            <a:endParaRPr/>
           </a:p>
         </p:txBody>
       </p:sp>
@@ -6051,6 +6098,7 @@
           <a:lstStyle/>
           <a:p>
             <a:pPr algn="ctr"/>
+            <a:endParaRPr/>
           </a:p>
         </p:txBody>
       </p:sp>
@@ -6166,6 +6214,7 @@
           <a:lstStyle/>
           <a:p>
             <a:pPr algn="ctr"/>
+            <a:endParaRPr/>
           </a:p>
         </p:txBody>
       </p:sp>
@@ -6281,6 +6330,7 @@
           <a:lstStyle/>
           <a:p>
             <a:pPr algn="ctr"/>
+            <a:endParaRPr/>
           </a:p>
         </p:txBody>
       </p:sp>
@@ -6363,7 +6413,7 @@
 </file>
 
 <file path=ppt/slides/slide4.xml><?xml version="1.0" encoding="utf-8"?>
-<p:sld xmlns:a="http://schemas.openxmlformats.org/drawingml/2006/main" xmlns:p="http://schemas.openxmlformats.org/presentationml/2006/main" xmlns:r="http://schemas.openxmlformats.org/officeDocument/2006/relationships">
+<p:sld xmlns:a="http://schemas.openxmlformats.org/drawingml/2006/main" xmlns:r="http://schemas.openxmlformats.org/officeDocument/2006/relationships" xmlns:p="http://schemas.openxmlformats.org/presentationml/2006/main">
   <p:cSld>
     <p:bg>
       <p:bgPr>
@@ -6379,7 +6429,14 @@
         <p:cNvGrpSpPr/>
         <p:nvPr/>
       </p:nvGrpSpPr>
-      <p:grpSpPr/>
+      <p:grpSpPr>
+        <a:xfrm>
+          <a:off x="0" y="0"/>
+          <a:ext cx="0" cy="0"/>
+          <a:chOff x="0" y="0"/>
+          <a:chExt cx="0" cy="0"/>
+        </a:xfrm>
+      </p:grpSpPr>
       <p:sp>
         <p:nvSpPr>
           <p:cNvPr id="2" name="Rectangle 1"/>
@@ -6420,6 +6477,7 @@
           <a:lstStyle/>
           <a:p>
             <a:pPr algn="ctr"/>
+            <a:endParaRPr/>
           </a:p>
         </p:txBody>
       </p:sp>
@@ -6535,6 +6593,7 @@
           <a:lstStyle/>
           <a:p>
             <a:pPr algn="ctr"/>
+            <a:endParaRPr/>
           </a:p>
         </p:txBody>
       </p:sp>
@@ -6578,6 +6637,7 @@
           <a:lstStyle/>
           <a:p>
             <a:pPr algn="ctr"/>
+            <a:endParaRPr/>
           </a:p>
         </p:txBody>
       </p:sp>
@@ -6798,6 +6858,7 @@
           <a:lstStyle/>
           <a:p>
             <a:pPr algn="ctr"/>
+            <a:endParaRPr/>
           </a:p>
         </p:txBody>
       </p:sp>
@@ -6841,6 +6902,7 @@
           <a:lstStyle/>
           <a:p>
             <a:pPr algn="ctr"/>
+            <a:endParaRPr/>
           </a:p>
         </p:txBody>
       </p:sp>
@@ -7061,6 +7123,7 @@
           <a:lstStyle/>
           <a:p>
             <a:pPr algn="ctr"/>
+            <a:endParaRPr/>
           </a:p>
         </p:txBody>
       </p:sp>
@@ -7104,6 +7167,7 @@
           <a:lstStyle/>
           <a:p>
             <a:pPr algn="ctr"/>
+            <a:endParaRPr/>
           </a:p>
         </p:txBody>
       </p:sp>
@@ -7278,121 +7342,6 @@
                 <a:latin typeface="Calibri"/>
               </a:rPr>
               <a:t>→ 6 支腳本 + 工具</a:t>
-            </a:r>
-          </a:p>
-        </p:txBody>
-      </p:sp>
-      <p:sp>
-        <p:nvSpPr>
-          <p:cNvPr id="26" name="Rectangle 25"/>
-          <p:cNvSpPr/>
-          <p:nvPr/>
-        </p:nvSpPr>
-        <p:spPr>
-          <a:xfrm>
-            <a:off x="411480" y="5120640"/>
-            <a:ext cx="11365992" cy="1005840"/>
-          </a:xfrm>
-          <a:prstGeom prst="rect">
-            <a:avLst/>
-          </a:prstGeom>
-          <a:solidFill>
-            <a:srgbClr val="1A2235"/>
-          </a:solidFill>
-          <a:ln w="12700">
-            <a:solidFill>
-              <a:srgbClr val="3B82F6"/>
-            </a:solidFill>
-          </a:ln>
-        </p:spPr>
-        <p:style>
-          <a:lnRef idx="1">
-            <a:schemeClr val="accent1"/>
-          </a:lnRef>
-          <a:fillRef idx="3">
-            <a:schemeClr val="accent1"/>
-          </a:fillRef>
-          <a:effectRef idx="2">
-            <a:schemeClr val="accent1"/>
-          </a:effectRef>
-          <a:fontRef idx="minor">
-            <a:schemeClr val="lt1"/>
-          </a:fontRef>
-        </p:style>
-        <p:txBody>
-          <a:bodyPr rtlCol="0" anchor="ctr"/>
-          <a:lstStyle/>
-          <a:p>
-            <a:pPr algn="ctr"/>
-          </a:p>
-        </p:txBody>
-      </p:sp>
-      <p:sp>
-        <p:nvSpPr>
-          <p:cNvPr id="27" name="TextBox 26"/>
-          <p:cNvSpPr txBox="1"/>
-          <p:nvPr/>
-        </p:nvSpPr>
-        <p:spPr>
-          <a:xfrm>
-            <a:off x="594360" y="5193792"/>
-            <a:ext cx="6400800" cy="411480"/>
-          </a:xfrm>
-          <a:prstGeom prst="rect">
-            <a:avLst/>
-          </a:prstGeom>
-          <a:noFill/>
-        </p:spPr>
-        <p:txBody>
-          <a:bodyPr wrap="square">
-            <a:spAutoFit/>
-          </a:bodyPr>
-          <a:lstStyle/>
-          <a:p>
-            <a:pPr algn="l"/>
-            <a:r>
-              <a:rPr sz="1400" b="1">
-                <a:solidFill>
-                  <a:srgbClr val="FFFFFF"/>
-                </a:solidFill>
-                <a:latin typeface="Calibri"/>
-              </a:rPr>
-              <a:t>⏰  自動化排程 — run_crawlers_daily.bat</a:t>
-            </a:r>
-          </a:p>
-        </p:txBody>
-      </p:sp>
-      <p:sp>
-        <p:nvSpPr>
-          <p:cNvPr id="28" name="TextBox 27"/>
-          <p:cNvSpPr txBox="1"/>
-          <p:nvPr/>
-        </p:nvSpPr>
-        <p:spPr>
-          <a:xfrm>
-            <a:off x="594360" y="5596128"/>
-            <a:ext cx="7315200" cy="365760"/>
-          </a:xfrm>
-          <a:prstGeom prst="rect">
-            <a:avLst/>
-          </a:prstGeom>
-          <a:noFill/>
-        </p:spPr>
-        <p:txBody>
-          <a:bodyPr wrap="square">
-            <a:spAutoFit/>
-          </a:bodyPr>
-          <a:lstStyle/>
-          <a:p>
-            <a:pPr algn="l"/>
-            <a:r>
-              <a:rPr sz="1200" b="0">
-                <a:solidFill>
-                  <a:srgbClr val="64748B"/>
-                </a:solidFill>
-                <a:latin typeface="Calibri"/>
-              </a:rPr>
-              <a:t>開機等待網路 → 清除舊進度 → 3 來源 × 3 Phase → 記錄日誌</a:t>
             </a:r>
           </a:p>
         </p:txBody>
@@ -7406,7 +7355,7 @@
 </file>
 
 <file path=ppt/slides/slide5.xml><?xml version="1.0" encoding="utf-8"?>
-<p:sld xmlns:a="http://schemas.openxmlformats.org/drawingml/2006/main" xmlns:p="http://schemas.openxmlformats.org/presentationml/2006/main" xmlns:r="http://schemas.openxmlformats.org/officeDocument/2006/relationships">
+<p:sld xmlns:a="http://schemas.openxmlformats.org/drawingml/2006/main" xmlns:r="http://schemas.openxmlformats.org/officeDocument/2006/relationships" xmlns:p="http://schemas.openxmlformats.org/presentationml/2006/main">
   <p:cSld>
     <p:bg>
       <p:bgPr>
@@ -7422,7 +7371,14 @@
         <p:cNvGrpSpPr/>
         <p:nvPr/>
       </p:nvGrpSpPr>
-      <p:grpSpPr/>
+      <p:grpSpPr>
+        <a:xfrm>
+          <a:off x="0" y="0"/>
+          <a:ext cx="0" cy="0"/>
+          <a:chOff x="0" y="0"/>
+          <a:chExt cx="0" cy="0"/>
+        </a:xfrm>
+      </p:grpSpPr>
       <p:sp>
         <p:nvSpPr>
           <p:cNvPr id="2" name="Rectangle 1"/>
@@ -7463,6 +7419,7 @@
           <a:lstStyle/>
           <a:p>
             <a:pPr algn="ctr"/>
+            <a:endParaRPr/>
           </a:p>
         </p:txBody>
       </p:sp>
@@ -7578,6 +7535,7 @@
           <a:lstStyle/>
           <a:p>
             <a:pPr algn="ctr"/>
+            <a:endParaRPr/>
           </a:p>
         </p:txBody>
       </p:sp>
@@ -7658,6 +7616,7 @@
           <a:lstStyle/>
           <a:p>
             <a:pPr algn="ctr"/>
+            <a:endParaRPr/>
           </a:p>
         </p:txBody>
       </p:sp>
@@ -7808,6 +7767,7 @@
           <a:lstStyle/>
           <a:p>
             <a:pPr algn="ctr"/>
+            <a:endParaRPr/>
           </a:p>
         </p:txBody>
       </p:sp>
@@ -7958,6 +7918,7 @@
           <a:lstStyle/>
           <a:p>
             <a:pPr algn="ctr"/>
+            <a:endParaRPr/>
           </a:p>
         </p:txBody>
       </p:sp>
@@ -8108,6 +8069,7 @@
           <a:lstStyle/>
           <a:p>
             <a:pPr algn="ctr"/>
+            <a:endParaRPr/>
           </a:p>
         </p:txBody>
       </p:sp>
@@ -8258,6 +8220,7 @@
           <a:lstStyle/>
           <a:p>
             <a:pPr algn="ctr"/>
+            <a:endParaRPr/>
           </a:p>
         </p:txBody>
       </p:sp>
@@ -8408,6 +8371,7 @@
           <a:lstStyle/>
           <a:p>
             <a:pPr algn="ctr"/>
+            <a:endParaRPr/>
           </a:p>
         </p:txBody>
       </p:sp>
@@ -8558,6 +8522,7 @@
           <a:lstStyle/>
           <a:p>
             <a:pPr algn="ctr"/>
+            <a:endParaRPr/>
           </a:p>
         </p:txBody>
       </p:sp>
@@ -8708,6 +8673,7 @@
           <a:lstStyle/>
           <a:p>
             <a:pPr algn="ctr"/>
+            <a:endParaRPr/>
           </a:p>
         </p:txBody>
       </p:sp>
@@ -8788,6 +8754,7 @@
           <a:lstStyle/>
           <a:p>
             <a:pPr algn="ctr"/>
+            <a:endParaRPr/>
           </a:p>
         </p:txBody>
       </p:sp>
@@ -8903,6 +8870,7 @@
           <a:lstStyle/>
           <a:p>
             <a:pPr algn="ctr"/>
+            <a:endParaRPr/>
           </a:p>
         </p:txBody>
       </p:sp>
@@ -9018,6 +8986,7 @@
           <a:lstStyle/>
           <a:p>
             <a:pPr algn="ctr"/>
+            <a:endParaRPr/>
           </a:p>
         </p:txBody>
       </p:sp>
@@ -9102,7 +9071,7 @@
 </file>
 
 <file path=ppt/slides/slide6.xml><?xml version="1.0" encoding="utf-8"?>
-<p:sld xmlns:a="http://schemas.openxmlformats.org/drawingml/2006/main" xmlns:p="http://schemas.openxmlformats.org/presentationml/2006/main" xmlns:r="http://schemas.openxmlformats.org/officeDocument/2006/relationships">
+<p:sld xmlns:a="http://schemas.openxmlformats.org/drawingml/2006/main" xmlns:r="http://schemas.openxmlformats.org/officeDocument/2006/relationships" xmlns:p="http://schemas.openxmlformats.org/presentationml/2006/main">
   <p:cSld>
     <p:bg>
       <p:bgPr>
@@ -9118,7 +9087,14 @@
         <p:cNvGrpSpPr/>
         <p:nvPr/>
       </p:nvGrpSpPr>
-      <p:grpSpPr/>
+      <p:grpSpPr>
+        <a:xfrm>
+          <a:off x="0" y="0"/>
+          <a:ext cx="0" cy="0"/>
+          <a:chOff x="0" y="0"/>
+          <a:chExt cx="0" cy="0"/>
+        </a:xfrm>
+      </p:grpSpPr>
       <p:sp>
         <p:nvSpPr>
           <p:cNvPr id="2" name="Rectangle 1"/>
@@ -9159,6 +9135,7 @@
           <a:lstStyle/>
           <a:p>
             <a:pPr algn="ctr"/>
+            <a:endParaRPr/>
           </a:p>
         </p:txBody>
       </p:sp>
@@ -9274,6 +9251,7 @@
           <a:lstStyle/>
           <a:p>
             <a:pPr algn="ctr"/>
+            <a:endParaRPr/>
           </a:p>
         </p:txBody>
       </p:sp>
@@ -9317,6 +9295,7 @@
           <a:lstStyle/>
           <a:p>
             <a:pPr algn="ctr"/>
+            <a:endParaRPr/>
           </a:p>
         </p:txBody>
       </p:sp>
@@ -9432,6 +9411,7 @@
           <a:lstStyle/>
           <a:p>
             <a:pPr algn="ctr"/>
+            <a:endParaRPr/>
           </a:p>
         </p:txBody>
       </p:sp>
@@ -9475,6 +9455,7 @@
           <a:lstStyle/>
           <a:p>
             <a:pPr algn="ctr"/>
+            <a:endParaRPr/>
           </a:p>
         </p:txBody>
       </p:sp>
@@ -9590,6 +9571,7 @@
           <a:lstStyle/>
           <a:p>
             <a:pPr algn="ctr"/>
+            <a:endParaRPr/>
           </a:p>
         </p:txBody>
       </p:sp>
@@ -9633,6 +9615,7 @@
           <a:lstStyle/>
           <a:p>
             <a:pPr algn="ctr"/>
+            <a:endParaRPr/>
           </a:p>
         </p:txBody>
       </p:sp>
@@ -9748,6 +9731,7 @@
           <a:lstStyle/>
           <a:p>
             <a:pPr algn="ctr"/>
+            <a:endParaRPr/>
           </a:p>
         </p:txBody>
       </p:sp>
@@ -9791,6 +9775,7 @@
           <a:lstStyle/>
           <a:p>
             <a:pPr algn="ctr"/>
+            <a:endParaRPr/>
           </a:p>
         </p:txBody>
       </p:sp>
@@ -9906,6 +9891,7 @@
           <a:lstStyle/>
           <a:p>
             <a:pPr algn="ctr"/>
+            <a:endParaRPr/>
           </a:p>
         </p:txBody>
       </p:sp>
@@ -9949,6 +9935,7 @@
           <a:lstStyle/>
           <a:p>
             <a:pPr algn="ctr"/>
+            <a:endParaRPr/>
           </a:p>
         </p:txBody>
       </p:sp>
@@ -10068,6 +10055,7 @@
           <a:lstStyle/>
           <a:p>
             <a:pPr algn="ctr"/>
+            <a:endParaRPr/>
           </a:p>
         </p:txBody>
       </p:sp>
@@ -10111,6 +10099,7 @@
           <a:lstStyle/>
           <a:p>
             <a:pPr algn="ctr"/>
+            <a:endParaRPr/>
           </a:p>
         </p:txBody>
       </p:sp>
@@ -10228,6 +10217,7 @@
           <a:lstStyle/>
           <a:p>
             <a:pPr algn="ctr"/>
+            <a:endParaRPr/>
           </a:p>
         </p:txBody>
       </p:sp>
@@ -10271,6 +10261,7 @@
           <a:lstStyle/>
           <a:p>
             <a:pPr algn="ctr"/>
+            <a:endParaRPr/>
           </a:p>
         </p:txBody>
       </p:sp>
@@ -10355,7 +10346,7 @@
 </file>
 
 <file path=ppt/slides/slide7.xml><?xml version="1.0" encoding="utf-8"?>
-<p:sld xmlns:a="http://schemas.openxmlformats.org/drawingml/2006/main" xmlns:p="http://schemas.openxmlformats.org/presentationml/2006/main" xmlns:r="http://schemas.openxmlformats.org/officeDocument/2006/relationships">
+<p:sld xmlns:a="http://schemas.openxmlformats.org/drawingml/2006/main" xmlns:r="http://schemas.openxmlformats.org/officeDocument/2006/relationships" xmlns:p="http://schemas.openxmlformats.org/presentationml/2006/main">
   <p:cSld>
     <p:bg>
       <p:bgPr>
@@ -10371,7 +10362,14 @@
         <p:cNvGrpSpPr/>
         <p:nvPr/>
       </p:nvGrpSpPr>
-      <p:grpSpPr/>
+      <p:grpSpPr>
+        <a:xfrm>
+          <a:off x="0" y="0"/>
+          <a:ext cx="0" cy="0"/>
+          <a:chOff x="0" y="0"/>
+          <a:chExt cx="0" cy="0"/>
+        </a:xfrm>
+      </p:grpSpPr>
       <p:sp>
         <p:nvSpPr>
           <p:cNvPr id="2" name="Rectangle 1"/>
@@ -10412,6 +10410,7 @@
           <a:lstStyle/>
           <a:p>
             <a:pPr algn="ctr"/>
+            <a:endParaRPr/>
           </a:p>
         </p:txBody>
       </p:sp>
@@ -10527,6 +10526,7 @@
           <a:lstStyle/>
           <a:p>
             <a:pPr algn="ctr"/>
+            <a:endParaRPr/>
           </a:p>
         </p:txBody>
       </p:sp>
@@ -10570,6 +10570,7 @@
           <a:lstStyle/>
           <a:p>
             <a:pPr algn="ctr"/>
+            <a:endParaRPr/>
           </a:p>
         </p:txBody>
       </p:sp>
@@ -10685,6 +10686,7 @@
           <a:lstStyle/>
           <a:p>
             <a:pPr algn="ctr"/>
+            <a:endParaRPr/>
           </a:p>
         </p:txBody>
       </p:sp>
@@ -10728,6 +10730,7 @@
           <a:lstStyle/>
           <a:p>
             <a:pPr algn="ctr"/>
+            <a:endParaRPr/>
           </a:p>
         </p:txBody>
       </p:sp>
@@ -10843,6 +10846,7 @@
           <a:lstStyle/>
           <a:p>
             <a:pPr algn="ctr"/>
+            <a:endParaRPr/>
           </a:p>
         </p:txBody>
       </p:sp>
@@ -10886,6 +10890,7 @@
           <a:lstStyle/>
           <a:p>
             <a:pPr algn="ctr"/>
+            <a:endParaRPr/>
           </a:p>
         </p:txBody>
       </p:sp>
@@ -11001,6 +11006,7 @@
           <a:lstStyle/>
           <a:p>
             <a:pPr algn="ctr"/>
+            <a:endParaRPr/>
           </a:p>
         </p:txBody>
       </p:sp>
@@ -11044,6 +11050,7 @@
           <a:lstStyle/>
           <a:p>
             <a:pPr algn="ctr"/>
+            <a:endParaRPr/>
           </a:p>
         </p:txBody>
       </p:sp>
@@ -11159,6 +11166,7 @@
           <a:lstStyle/>
           <a:p>
             <a:pPr algn="ctr"/>
+            <a:endParaRPr/>
           </a:p>
         </p:txBody>
       </p:sp>
@@ -11202,6 +11210,7 @@
           <a:lstStyle/>
           <a:p>
             <a:pPr algn="ctr"/>
+            <a:endParaRPr/>
           </a:p>
         </p:txBody>
       </p:sp>
@@ -11317,6 +11326,7 @@
           <a:lstStyle/>
           <a:p>
             <a:pPr algn="ctr"/>
+            <a:endParaRPr/>
           </a:p>
         </p:txBody>
       </p:sp>
@@ -11407,7 +11417,7 @@
 </file>
 
 <file path=ppt/slides/slide8.xml><?xml version="1.0" encoding="utf-8"?>
-<p:sld xmlns:a="http://schemas.openxmlformats.org/drawingml/2006/main" xmlns:p="http://schemas.openxmlformats.org/presentationml/2006/main" xmlns:r="http://schemas.openxmlformats.org/officeDocument/2006/relationships">
+<p:sld xmlns:a="http://schemas.openxmlformats.org/drawingml/2006/main" xmlns:r="http://schemas.openxmlformats.org/officeDocument/2006/relationships" xmlns:p="http://schemas.openxmlformats.org/presentationml/2006/main">
   <p:cSld>
     <p:bg>
       <p:bgPr>
@@ -11423,7 +11433,14 @@
         <p:cNvGrpSpPr/>
         <p:nvPr/>
       </p:nvGrpSpPr>
-      <p:grpSpPr/>
+      <p:grpSpPr>
+        <a:xfrm>
+          <a:off x="0" y="0"/>
+          <a:ext cx="0" cy="0"/>
+          <a:chOff x="0" y="0"/>
+          <a:chExt cx="0" cy="0"/>
+        </a:xfrm>
+      </p:grpSpPr>
       <p:sp>
         <p:nvSpPr>
           <p:cNvPr id="2" name="Rectangle 1"/>
@@ -11464,6 +11481,7 @@
           <a:lstStyle/>
           <a:p>
             <a:pPr algn="ctr"/>
+            <a:endParaRPr/>
           </a:p>
         </p:txBody>
       </p:sp>
@@ -11614,6 +11632,7 @@
           <a:lstStyle/>
           <a:p>
             <a:pPr algn="ctr"/>
+            <a:endParaRPr/>
           </a:p>
         </p:txBody>
       </p:sp>
@@ -11694,6 +11713,7 @@
           <a:lstStyle/>
           <a:p>
             <a:pPr algn="ctr"/>
+            <a:endParaRPr/>
           </a:p>
         </p:txBody>
       </p:sp>
@@ -11774,6 +11794,7 @@
           <a:lstStyle/>
           <a:p>
             <a:pPr algn="ctr"/>
+            <a:endParaRPr/>
           </a:p>
         </p:txBody>
       </p:sp>
@@ -11854,6 +11875,7 @@
           <a:lstStyle/>
           <a:p>
             <a:pPr algn="ctr"/>
+            <a:endParaRPr/>
           </a:p>
         </p:txBody>
       </p:sp>
@@ -11934,6 +11956,7 @@
           <a:lstStyle/>
           <a:p>
             <a:pPr algn="ctr"/>
+            <a:endParaRPr/>
           </a:p>
         </p:txBody>
       </p:sp>
@@ -12014,6 +12037,7 @@
           <a:lstStyle/>
           <a:p>
             <a:pPr algn="ctr"/>
+            <a:endParaRPr/>
           </a:p>
         </p:txBody>
       </p:sp>
@@ -12094,6 +12118,7 @@
           <a:lstStyle/>
           <a:p>
             <a:pPr algn="ctr"/>
+            <a:endParaRPr/>
           </a:p>
         </p:txBody>
       </p:sp>
@@ -12174,6 +12199,7 @@
           <a:lstStyle/>
           <a:p>
             <a:pPr algn="ctr"/>
+            <a:endParaRPr/>
           </a:p>
         </p:txBody>
       </p:sp>
@@ -12289,6 +12315,7 @@
           <a:lstStyle/>
           <a:p>
             <a:pPr algn="ctr"/>
+            <a:endParaRPr/>
           </a:p>
         </p:txBody>
       </p:sp>
@@ -12369,6 +12396,7 @@
           <a:lstStyle/>
           <a:p>
             <a:pPr algn="ctr"/>
+            <a:endParaRPr/>
           </a:p>
         </p:txBody>
       </p:sp>
@@ -12449,6 +12477,7 @@
           <a:lstStyle/>
           <a:p>
             <a:pPr algn="ctr"/>
+            <a:endParaRPr/>
           </a:p>
         </p:txBody>
       </p:sp>
@@ -12529,6 +12558,7 @@
           <a:lstStyle/>
           <a:p>
             <a:pPr algn="ctr"/>
+            <a:endParaRPr/>
           </a:p>
         </p:txBody>
       </p:sp>
@@ -12609,6 +12639,7 @@
           <a:lstStyle/>
           <a:p>
             <a:pPr algn="ctr"/>
+            <a:endParaRPr/>
           </a:p>
         </p:txBody>
       </p:sp>
@@ -12689,6 +12720,7 @@
           <a:lstStyle/>
           <a:p>
             <a:pPr algn="ctr"/>
+            <a:endParaRPr/>
           </a:p>
         </p:txBody>
       </p:sp>
@@ -12769,6 +12801,7 @@
           <a:lstStyle/>
           <a:p>
             <a:pPr algn="ctr"/>
+            <a:endParaRPr/>
           </a:p>
         </p:txBody>
       </p:sp>
@@ -12838,751 +12871,6 @@
                 <a:latin typeface="Calibri"/>
               </a:rPr>
               <a:t>API Keys 改用 .env 環境變數  ·  git filter-repo 清除歷史洩漏  ·  .gitignore 防再次 commit</a:t>
-            </a:r>
-          </a:p>
-        </p:txBody>
-      </p:sp>
-    </p:spTree>
-  </p:cSld>
-  <p:clrMapOvr>
-    <a:masterClrMapping/>
-  </p:clrMapOvr>
-</p:sld>
-</file>
-
-<file path=ppt/slides/slide9.xml><?xml version="1.0" encoding="utf-8"?>
-<p:sld xmlns:a="http://schemas.openxmlformats.org/drawingml/2006/main" xmlns:p="http://schemas.openxmlformats.org/presentationml/2006/main" xmlns:r="http://schemas.openxmlformats.org/officeDocument/2006/relationships">
-  <p:cSld>
-    <p:bg>
-      <p:bgPr>
-        <a:solidFill>
-          <a:srgbClr val="0A0E1A"/>
-        </a:solidFill>
-        <a:effectLst/>
-      </p:bgPr>
-    </p:bg>
-    <p:spTree>
-      <p:nvGrpSpPr>
-        <p:cNvPr id="1" name=""/>
-        <p:cNvGrpSpPr/>
-        <p:nvPr/>
-      </p:nvGrpSpPr>
-      <p:grpSpPr/>
-      <p:sp>
-        <p:nvSpPr>
-          <p:cNvPr id="2" name="Rectangle 1"/>
-          <p:cNvSpPr/>
-          <p:nvPr/>
-        </p:nvSpPr>
-        <p:spPr>
-          <a:xfrm>
-            <a:off x="0" y="0"/>
-            <a:ext cx="12188952" cy="50800"/>
-          </a:xfrm>
-          <a:prstGeom prst="rect">
-            <a:avLst/>
-          </a:prstGeom>
-          <a:solidFill>
-            <a:srgbClr val="8B5CF6"/>
-          </a:solidFill>
-          <a:ln>
-            <a:noFill/>
-          </a:ln>
-        </p:spPr>
-        <p:style>
-          <a:lnRef idx="1">
-            <a:schemeClr val="accent1"/>
-          </a:lnRef>
-          <a:fillRef idx="3">
-            <a:schemeClr val="accent1"/>
-          </a:fillRef>
-          <a:effectRef idx="2">
-            <a:schemeClr val="accent1"/>
-          </a:effectRef>
-          <a:fontRef idx="minor">
-            <a:schemeClr val="lt1"/>
-          </a:fontRef>
-        </p:style>
-        <p:txBody>
-          <a:bodyPr rtlCol="0" anchor="ctr"/>
-          <a:lstStyle/>
-          <a:p>
-            <a:pPr algn="ctr"/>
-          </a:p>
-        </p:txBody>
-      </p:sp>
-      <p:sp>
-        <p:nvSpPr>
-          <p:cNvPr id="3" name="TextBox 2"/>
-          <p:cNvSpPr txBox="1"/>
-          <p:nvPr/>
-        </p:nvSpPr>
-        <p:spPr>
-          <a:xfrm>
-            <a:off x="640080" y="502920"/>
-            <a:ext cx="5486400" cy="320040"/>
-          </a:xfrm>
-          <a:prstGeom prst="rect">
-            <a:avLst/>
-          </a:prstGeom>
-          <a:noFill/>
-        </p:spPr>
-        <p:txBody>
-          <a:bodyPr wrap="square">
-            <a:spAutoFit/>
-          </a:bodyPr>
-          <a:lstStyle/>
-          <a:p>
-            <a:pPr algn="l"/>
-            <a:r>
-              <a:rPr sz="1000" b="1">
-                <a:solidFill>
-                  <a:srgbClr val="3B82F6"/>
-                </a:solidFill>
-                <a:latin typeface="Calibri"/>
-              </a:rPr>
-              <a:t>ROADMAP</a:t>
-            </a:r>
-          </a:p>
-        </p:txBody>
-      </p:sp>
-      <p:sp>
-        <p:nvSpPr>
-          <p:cNvPr id="4" name="TextBox 3"/>
-          <p:cNvSpPr txBox="1"/>
-          <p:nvPr/>
-        </p:nvSpPr>
-        <p:spPr>
-          <a:xfrm>
-            <a:off x="640080" y="822960"/>
-            <a:ext cx="10881360" cy="914400"/>
-          </a:xfrm>
-          <a:prstGeom prst="rect">
-            <a:avLst/>
-          </a:prstGeom>
-          <a:noFill/>
-        </p:spPr>
-        <p:txBody>
-          <a:bodyPr wrap="square">
-            <a:spAutoFit/>
-          </a:bodyPr>
-          <a:lstStyle/>
-          <a:p>
-            <a:pPr algn="l"/>
-            <a:r>
-              <a:rPr sz="3600" b="1">
-                <a:solidFill>
-                  <a:srgbClr val="FFFFFF"/>
-                </a:solidFill>
-                <a:latin typeface="Calibri"/>
-              </a:rPr>
-              <a:t>未來規劃</a:t>
-            </a:r>
-          </a:p>
-        </p:txBody>
-      </p:sp>
-      <p:sp>
-        <p:nvSpPr>
-          <p:cNvPr id="5" name="Rectangle 4"/>
-          <p:cNvSpPr/>
-          <p:nvPr/>
-        </p:nvSpPr>
-        <p:spPr>
-          <a:xfrm>
-            <a:off x="457200" y="1874519"/>
-            <a:ext cx="5486400" cy="3200400"/>
-          </a:xfrm>
-          <a:prstGeom prst="rect">
-            <a:avLst/>
-          </a:prstGeom>
-          <a:solidFill>
-            <a:srgbClr val="1A2235"/>
-          </a:solidFill>
-          <a:ln w="19050">
-            <a:solidFill>
-              <a:srgbClr val="3B82F6"/>
-            </a:solidFill>
-          </a:ln>
-        </p:spPr>
-        <p:style>
-          <a:lnRef idx="1">
-            <a:schemeClr val="accent1"/>
-          </a:lnRef>
-          <a:fillRef idx="3">
-            <a:schemeClr val="accent1"/>
-          </a:fillRef>
-          <a:effectRef idx="2">
-            <a:schemeClr val="accent1"/>
-          </a:effectRef>
-          <a:fontRef idx="minor">
-            <a:schemeClr val="lt1"/>
-          </a:fontRef>
-        </p:style>
-        <p:txBody>
-          <a:bodyPr rtlCol="0" anchor="ctr"/>
-          <a:lstStyle/>
-          <a:p>
-            <a:pPr algn="ctr"/>
-          </a:p>
-        </p:txBody>
-      </p:sp>
-      <p:sp>
-        <p:nvSpPr>
-          <p:cNvPr id="6" name="Rectangle 5"/>
-          <p:cNvSpPr/>
-          <p:nvPr/>
-        </p:nvSpPr>
-        <p:spPr>
-          <a:xfrm>
-            <a:off x="457200" y="1874519"/>
-            <a:ext cx="5486400" cy="38100"/>
-          </a:xfrm>
-          <a:prstGeom prst="rect">
-            <a:avLst/>
-          </a:prstGeom>
-          <a:solidFill>
-            <a:srgbClr val="3B82F6"/>
-          </a:solidFill>
-          <a:ln>
-            <a:noFill/>
-          </a:ln>
-        </p:spPr>
-        <p:style>
-          <a:lnRef idx="1">
-            <a:schemeClr val="accent1"/>
-          </a:lnRef>
-          <a:fillRef idx="3">
-            <a:schemeClr val="accent1"/>
-          </a:fillRef>
-          <a:effectRef idx="2">
-            <a:schemeClr val="accent1"/>
-          </a:effectRef>
-          <a:fontRef idx="minor">
-            <a:schemeClr val="lt1"/>
-          </a:fontRef>
-        </p:style>
-        <p:txBody>
-          <a:bodyPr rtlCol="0" anchor="ctr"/>
-          <a:lstStyle/>
-          <a:p>
-            <a:pPr algn="ctr"/>
-          </a:p>
-        </p:txBody>
-      </p:sp>
-      <p:sp>
-        <p:nvSpPr>
-          <p:cNvPr id="7" name="TextBox 6"/>
-          <p:cNvSpPr txBox="1"/>
-          <p:nvPr/>
-        </p:nvSpPr>
-        <p:spPr>
-          <a:xfrm>
-            <a:off x="594360" y="1938528"/>
-            <a:ext cx="5212080" cy="457200"/>
-          </a:xfrm>
-          <a:prstGeom prst="rect">
-            <a:avLst/>
-          </a:prstGeom>
-          <a:noFill/>
-        </p:spPr>
-        <p:txBody>
-          <a:bodyPr wrap="square">
-            <a:spAutoFit/>
-          </a:bodyPr>
-          <a:lstStyle/>
-          <a:p>
-            <a:pPr algn="l"/>
-            <a:r>
-              <a:rPr sz="1500" b="1">
-                <a:solidFill>
-                  <a:srgbClr val="3B82F6"/>
-                </a:solidFill>
-                <a:latin typeface="Calibri"/>
-              </a:rPr>
-              <a:t>🔥  短期優化</a:t>
-            </a:r>
-          </a:p>
-        </p:txBody>
-      </p:sp>
-      <p:sp>
-        <p:nvSpPr>
-          <p:cNvPr id="8" name="TextBox 7"/>
-          <p:cNvSpPr txBox="1"/>
-          <p:nvPr/>
-        </p:nvSpPr>
-        <p:spPr>
-          <a:xfrm>
-            <a:off x="594360" y="2487168"/>
-            <a:ext cx="5212080" cy="457200"/>
-          </a:xfrm>
-          <a:prstGeom prst="rect">
-            <a:avLst/>
-          </a:prstGeom>
-          <a:noFill/>
-        </p:spPr>
-        <p:txBody>
-          <a:bodyPr wrap="square">
-            <a:spAutoFit/>
-          </a:bodyPr>
-          <a:lstStyle/>
-          <a:p>
-            <a:pPr algn="l"/>
-            <a:r>
-              <a:rPr sz="1200" b="0">
-                <a:solidFill>
-                  <a:srgbClr val="E2E8F0"/>
-                </a:solidFill>
-                <a:latin typeface="Calibri"/>
-              </a:rPr>
-              <a:t>→  週對比功能（本周 vs 上周）</a:t>
-            </a:r>
-          </a:p>
-        </p:txBody>
-      </p:sp>
-      <p:sp>
-        <p:nvSpPr>
-          <p:cNvPr id="9" name="TextBox 8"/>
-          <p:cNvSpPr txBox="1"/>
-          <p:nvPr/>
-        </p:nvSpPr>
-        <p:spPr>
-          <a:xfrm>
-            <a:off x="594360" y="3017520"/>
-            <a:ext cx="5212080" cy="457200"/>
-          </a:xfrm>
-          <a:prstGeom prst="rect">
-            <a:avLst/>
-          </a:prstGeom>
-          <a:noFill/>
-        </p:spPr>
-        <p:txBody>
-          <a:bodyPr wrap="square">
-            <a:spAutoFit/>
-          </a:bodyPr>
-          <a:lstStyle/>
-          <a:p>
-            <a:pPr algn="l"/>
-            <a:r>
-              <a:rPr sz="1200" b="0">
-                <a:solidFill>
-                  <a:srgbClr val="E2E8F0"/>
-                </a:solidFill>
-                <a:latin typeface="Calibri"/>
-              </a:rPr>
-              <a:t>→  行業分類分析</a:t>
-            </a:r>
-          </a:p>
-        </p:txBody>
-      </p:sp>
-      <p:sp>
-        <p:nvSpPr>
-          <p:cNvPr id="10" name="TextBox 9"/>
-          <p:cNvSpPr txBox="1"/>
-          <p:nvPr/>
-        </p:nvSpPr>
-        <p:spPr>
-          <a:xfrm>
-            <a:off x="594360" y="3547872"/>
-            <a:ext cx="5212080" cy="457200"/>
-          </a:xfrm>
-          <a:prstGeom prst="rect">
-            <a:avLst/>
-          </a:prstGeom>
-          <a:noFill/>
-        </p:spPr>
-        <p:txBody>
-          <a:bodyPr wrap="square">
-            <a:spAutoFit/>
-          </a:bodyPr>
-          <a:lstStyle/>
-          <a:p>
-            <a:pPr algn="l"/>
-            <a:r>
-              <a:rPr sz="1200" b="0">
-                <a:solidFill>
-                  <a:srgbClr val="E2E8F0"/>
-                </a:solidFill>
-                <a:latin typeface="Calibri"/>
-              </a:rPr>
-              <a:t>→  移動端 Dashboard 優化</a:t>
-            </a:r>
-          </a:p>
-        </p:txBody>
-      </p:sp>
-      <p:sp>
-        <p:nvSpPr>
-          <p:cNvPr id="11" name="TextBox 10"/>
-          <p:cNvSpPr txBox="1"/>
-          <p:nvPr/>
-        </p:nvSpPr>
-        <p:spPr>
-          <a:xfrm>
-            <a:off x="594360" y="4078224"/>
-            <a:ext cx="5212080" cy="457200"/>
-          </a:xfrm>
-          <a:prstGeom prst="rect">
-            <a:avLst/>
-          </a:prstGeom>
-          <a:noFill/>
-        </p:spPr>
-        <p:txBody>
-          <a:bodyPr wrap="square">
-            <a:spAutoFit/>
-          </a:bodyPr>
-          <a:lstStyle/>
-          <a:p>
-            <a:pPr algn="l"/>
-            <a:r>
-              <a:rPr sz="1200" b="0">
-                <a:solidFill>
-                  <a:srgbClr val="E2E8F0"/>
-                </a:solidFill>
-                <a:latin typeface="Calibri"/>
-              </a:rPr>
-              <a:t>→  LINE Bot 圖片回覆</a:t>
-            </a:r>
-          </a:p>
-        </p:txBody>
-      </p:sp>
-      <p:sp>
-        <p:nvSpPr>
-          <p:cNvPr id="12" name="Rectangle 11"/>
-          <p:cNvSpPr/>
-          <p:nvPr/>
-        </p:nvSpPr>
-        <p:spPr>
-          <a:xfrm>
-            <a:off x="6263640" y="1874519"/>
-            <a:ext cx="5486400" cy="3200400"/>
-          </a:xfrm>
-          <a:prstGeom prst="rect">
-            <a:avLst/>
-          </a:prstGeom>
-          <a:solidFill>
-            <a:srgbClr val="1A2235"/>
-          </a:solidFill>
-          <a:ln w="19050">
-            <a:solidFill>
-              <a:srgbClr val="8B5CF6"/>
-            </a:solidFill>
-          </a:ln>
-        </p:spPr>
-        <p:style>
-          <a:lnRef idx="1">
-            <a:schemeClr val="accent1"/>
-          </a:lnRef>
-          <a:fillRef idx="3">
-            <a:schemeClr val="accent1"/>
-          </a:fillRef>
-          <a:effectRef idx="2">
-            <a:schemeClr val="accent1"/>
-          </a:effectRef>
-          <a:fontRef idx="minor">
-            <a:schemeClr val="lt1"/>
-          </a:fontRef>
-        </p:style>
-        <p:txBody>
-          <a:bodyPr rtlCol="0" anchor="ctr"/>
-          <a:lstStyle/>
-          <a:p>
-            <a:pPr algn="ctr"/>
-          </a:p>
-        </p:txBody>
-      </p:sp>
-      <p:sp>
-        <p:nvSpPr>
-          <p:cNvPr id="13" name="Rectangle 12"/>
-          <p:cNvSpPr/>
-          <p:nvPr/>
-        </p:nvSpPr>
-        <p:spPr>
-          <a:xfrm>
-            <a:off x="6263640" y="1874519"/>
-            <a:ext cx="5486400" cy="38100"/>
-          </a:xfrm>
-          <a:prstGeom prst="rect">
-            <a:avLst/>
-          </a:prstGeom>
-          <a:solidFill>
-            <a:srgbClr val="8B5CF6"/>
-          </a:solidFill>
-          <a:ln>
-            <a:noFill/>
-          </a:ln>
-        </p:spPr>
-        <p:style>
-          <a:lnRef idx="1">
-            <a:schemeClr val="accent1"/>
-          </a:lnRef>
-          <a:fillRef idx="3">
-            <a:schemeClr val="accent1"/>
-          </a:fillRef>
-          <a:effectRef idx="2">
-            <a:schemeClr val="accent1"/>
-          </a:effectRef>
-          <a:fontRef idx="minor">
-            <a:schemeClr val="lt1"/>
-          </a:fontRef>
-        </p:style>
-        <p:txBody>
-          <a:bodyPr rtlCol="0" anchor="ctr"/>
-          <a:lstStyle/>
-          <a:p>
-            <a:pPr algn="ctr"/>
-          </a:p>
-        </p:txBody>
-      </p:sp>
-      <p:sp>
-        <p:nvSpPr>
-          <p:cNvPr id="14" name="TextBox 13"/>
-          <p:cNvSpPr txBox="1"/>
-          <p:nvPr/>
-        </p:nvSpPr>
-        <p:spPr>
-          <a:xfrm>
-            <a:off x="6400800" y="1938528"/>
-            <a:ext cx="5212080" cy="457200"/>
-          </a:xfrm>
-          <a:prstGeom prst="rect">
-            <a:avLst/>
-          </a:prstGeom>
-          <a:noFill/>
-        </p:spPr>
-        <p:txBody>
-          <a:bodyPr wrap="square">
-            <a:spAutoFit/>
-          </a:bodyPr>
-          <a:lstStyle/>
-          <a:p>
-            <a:pPr algn="l"/>
-            <a:r>
-              <a:rPr sz="1500" b="1">
-                <a:solidFill>
-                  <a:srgbClr val="8B5CF6"/>
-                </a:solidFill>
-                <a:latin typeface="Calibri"/>
-              </a:rPr>
-              <a:t>🚀  長期擴展</a:t>
-            </a:r>
-          </a:p>
-        </p:txBody>
-      </p:sp>
-      <p:sp>
-        <p:nvSpPr>
-          <p:cNvPr id="15" name="TextBox 14"/>
-          <p:cNvSpPr txBox="1"/>
-          <p:nvPr/>
-        </p:nvSpPr>
-        <p:spPr>
-          <a:xfrm>
-            <a:off x="6400800" y="2487168"/>
-            <a:ext cx="5212080" cy="457200"/>
-          </a:xfrm>
-          <a:prstGeom prst="rect">
-            <a:avLst/>
-          </a:prstGeom>
-          <a:noFill/>
-        </p:spPr>
-        <p:txBody>
-          <a:bodyPr wrap="square">
-            <a:spAutoFit/>
-          </a:bodyPr>
-          <a:lstStyle/>
-          <a:p>
-            <a:pPr algn="l"/>
-            <a:r>
-              <a:rPr sz="1200" b="0">
-                <a:solidFill>
-                  <a:srgbClr val="E2E8F0"/>
-                </a:solidFill>
-                <a:latin typeface="Calibri"/>
-              </a:rPr>
-              <a:t>→  自訂時間範圍查詢（3/14/30 天）</a:t>
-            </a:r>
-          </a:p>
-        </p:txBody>
-      </p:sp>
-      <p:sp>
-        <p:nvSpPr>
-          <p:cNvPr id="16" name="TextBox 15"/>
-          <p:cNvSpPr txBox="1"/>
-          <p:nvPr/>
-        </p:nvSpPr>
-        <p:spPr>
-          <a:xfrm>
-            <a:off x="6400800" y="3017520"/>
-            <a:ext cx="5212080" cy="457200"/>
-          </a:xfrm>
-          <a:prstGeom prst="rect">
-            <a:avLst/>
-          </a:prstGeom>
-          <a:noFill/>
-        </p:spPr>
-        <p:txBody>
-          <a:bodyPr wrap="square">
-            <a:spAutoFit/>
-          </a:bodyPr>
-          <a:lstStyle/>
-          <a:p>
-            <a:pPr algn="l"/>
-            <a:r>
-              <a:rPr sz="1200" b="0">
-                <a:solidFill>
-                  <a:srgbClr val="E2E8F0"/>
-                </a:solidFill>
-                <a:latin typeface="Calibri"/>
-              </a:rPr>
-              <a:t>→  情緒異常波動預警通知</a:t>
-            </a:r>
-          </a:p>
-        </p:txBody>
-      </p:sp>
-      <p:sp>
-        <p:nvSpPr>
-          <p:cNvPr id="17" name="TextBox 16"/>
-          <p:cNvSpPr txBox="1"/>
-          <p:nvPr/>
-        </p:nvSpPr>
-        <p:spPr>
-          <a:xfrm>
-            <a:off x="6400800" y="3547872"/>
-            <a:ext cx="5212080" cy="457200"/>
-          </a:xfrm>
-          <a:prstGeom prst="rect">
-            <a:avLst/>
-          </a:prstGeom>
-          <a:noFill/>
-        </p:spPr>
-        <p:txBody>
-          <a:bodyPr wrap="square">
-            <a:spAutoFit/>
-          </a:bodyPr>
-          <a:lstStyle/>
-          <a:p>
-            <a:pPr algn="l"/>
-            <a:r>
-              <a:rPr sz="1200" b="0">
-                <a:solidFill>
-                  <a:srgbClr val="E2E8F0"/>
-                </a:solidFill>
-                <a:latin typeface="Calibri"/>
-              </a:rPr>
-              <a:t>→  匯出 PDF 報告</a:t>
-            </a:r>
-          </a:p>
-        </p:txBody>
-      </p:sp>
-      <p:sp>
-        <p:nvSpPr>
-          <p:cNvPr id="18" name="TextBox 17"/>
-          <p:cNvSpPr txBox="1"/>
-          <p:nvPr/>
-        </p:nvSpPr>
-        <p:spPr>
-          <a:xfrm>
-            <a:off x="6400800" y="4078224"/>
-            <a:ext cx="5212080" cy="457200"/>
-          </a:xfrm>
-          <a:prstGeom prst="rect">
-            <a:avLst/>
-          </a:prstGeom>
-          <a:noFill/>
-        </p:spPr>
-        <p:txBody>
-          <a:bodyPr wrap="square">
-            <a:spAutoFit/>
-          </a:bodyPr>
-          <a:lstStyle/>
-          <a:p>
-            <a:pPr algn="l"/>
-            <a:r>
-              <a:rPr sz="1200" b="0">
-                <a:solidFill>
-                  <a:srgbClr val="E2E8F0"/>
-                </a:solidFill>
-                <a:latin typeface="Calibri"/>
-              </a:rPr>
-              <a:t>→  郵件訂閱功能</a:t>
-            </a:r>
-          </a:p>
-        </p:txBody>
-      </p:sp>
-      <p:sp>
-        <p:nvSpPr>
-          <p:cNvPr id="19" name="Rectangle 18"/>
-          <p:cNvSpPr/>
-          <p:nvPr/>
-        </p:nvSpPr>
-        <p:spPr>
-          <a:xfrm>
-            <a:off x="457200" y="5394960"/>
-            <a:ext cx="11274552" cy="1097280"/>
-          </a:xfrm>
-          <a:prstGeom prst="rect">
-            <a:avLst/>
-          </a:prstGeom>
-          <a:solidFill>
-            <a:srgbClr val="0D1A38"/>
-          </a:solidFill>
-          <a:ln w="12700">
-            <a:solidFill>
-              <a:srgbClr val="3B82F6"/>
-            </a:solidFill>
-          </a:ln>
-        </p:spPr>
-        <p:style>
-          <a:lnRef idx="1">
-            <a:schemeClr val="accent1"/>
-          </a:lnRef>
-          <a:fillRef idx="3">
-            <a:schemeClr val="accent1"/>
-          </a:fillRef>
-          <a:effectRef idx="2">
-            <a:schemeClr val="accent1"/>
-          </a:effectRef>
-          <a:fontRef idx="minor">
-            <a:schemeClr val="lt1"/>
-          </a:fontRef>
-        </p:style>
-        <p:txBody>
-          <a:bodyPr rtlCol="0" anchor="ctr"/>
-          <a:lstStyle/>
-          <a:p>
-            <a:pPr algn="ctr"/>
-          </a:p>
-        </p:txBody>
-      </p:sp>
-      <p:sp>
-        <p:nvSpPr>
-          <p:cNvPr id="20" name="TextBox 19"/>
-          <p:cNvSpPr txBox="1"/>
-          <p:nvPr/>
-        </p:nvSpPr>
-        <p:spPr>
-          <a:xfrm>
-            <a:off x="457200" y="5486400"/>
-            <a:ext cx="11274552" cy="822960"/>
-          </a:xfrm>
-          <a:prstGeom prst="rect">
-            <a:avLst/>
-          </a:prstGeom>
-          <a:noFill/>
-        </p:spPr>
-        <p:txBody>
-          <a:bodyPr wrap="square">
-            <a:spAutoFit/>
-          </a:bodyPr>
-          <a:lstStyle/>
-          <a:p>
-            <a:pPr algn="ctr"/>
-            <a:r>
-              <a:rPr sz="2400" b="1">
-                <a:solidFill>
-                  <a:srgbClr val="FFFFFF"/>
-                </a:solidFill>
-                <a:latin typeface="Calibri"/>
-              </a:rPr>
-              <a:t>🎉  謝謝觀看   ·   StockPulse  ·  2026</a:t>
             </a:r>
           </a:p>
         </p:txBody>

</xml_diff>